<commit_message>
feat: add document generation skills and security tests
- Introduced docker-compose.yml for service orchestration.
- Added markdown guides for creating DOCX, PDF, and PPTX documents.
- Implemented a read_skill tool to load document generation guides dynamically.
- Created security tests to validate code execution and pip package installations.
- Enhanced HTML interface for agent tool calls with improved styling and functionality.
</commit_message>
<xml_diff>
--- a/data/rag_presentation.pptx
+++ b/data/rag_presentation.pptx
@@ -9,8 +9,13 @@
     <p:sldId id="257" r:id="rId8"/>
     <p:sldId id="258" r:id="rId9"/>
     <p:sldId id="259" r:id="rId10"/>
+    <p:sldId id="260" r:id="rId11"/>
+    <p:sldId id="261" r:id="rId12"/>
+    <p:sldId id="262" r:id="rId13"/>
+    <p:sldId id="263" r:id="rId14"/>
+    <p:sldId id="264" r:id="rId15"/>
   </p:sldIdLst>
-  <p:sldSz cx="9144000" cy="6858000" type="screen4x3"/>
+  <p:sldSz cx="14630400" cy="8229600" type="screen4x3"/>
   <p:notesSz cx="6858000" cy="9144000"/>
   <p:defaultTextStyle>
     <a:defPPr>
@@ -3084,6 +3089,14 @@
 <file path=ppt/slides/slide1.xml><?xml version="1.0" encoding="utf-8"?>
 <p:sld xmlns:a="http://schemas.openxmlformats.org/drawingml/2006/main" xmlns:p="http://schemas.openxmlformats.org/presentationml/2006/main" xmlns:r="http://schemas.openxmlformats.org/officeDocument/2006/relationships">
   <p:cSld>
+    <p:bg>
+      <p:bgPr>
+        <a:solidFill>
+          <a:srgbClr val="065A82"/>
+        </a:solidFill>
+        <a:effectLst/>
+      </p:bgPr>
+    </p:bg>
     <p:spTree>
       <p:nvGrpSpPr>
         <p:cNvPr id="1" name=""/>
@@ -3098,14 +3111,46 @@
             <a:spLocks noGrp="1"/>
           </p:cNvSpPr>
           <p:nvPr>
-            <p:ph type="ctrTitle"/>
-          </p:nvPr>
-        </p:nvSpPr>
-        <p:spPr/>
-        <p:txBody>
-          <a:bodyPr/>
-          <a:lstStyle/>
-          <a:p>
+            <p:ph type="title"/>
+          </p:nvPr>
+        </p:nvSpPr>
+        <p:spPr/>
+        <p:txBody>
+          <a:bodyPr/>
+          <a:lstStyle/>
+          <a:p/>
+        </p:txBody>
+      </p:sp>
+      <p:sp>
+        <p:nvSpPr>
+          <p:cNvPr id="3" name="TextBox 2"/>
+          <p:cNvSpPr txBox="1"/>
+          <p:nvPr/>
+        </p:nvSpPr>
+        <p:spPr>
+          <a:xfrm>
+            <a:off x="914400" y="2743200"/>
+            <a:ext cx="12801600" cy="1828800"/>
+          </a:xfrm>
+          <a:prstGeom prst="rect">
+            <a:avLst/>
+          </a:prstGeom>
+          <a:noFill/>
+        </p:spPr>
+        <p:txBody>
+          <a:bodyPr wrap="none">
+            <a:spAutoFit/>
+          </a:bodyPr>
+          <a:lstStyle/>
+          <a:p>
+            <a:pPr algn="ctr">
+              <a:defRPr sz="4400" b="1">
+                <a:solidFill>
+                  <a:srgbClr val="FFFFFF"/>
+                </a:solidFill>
+                <a:latin typeface="Arial"/>
+              </a:defRPr>
+            </a:pPr>
             <a:r>
               <a:t>Retrieval-Augmented Generation (RAG)</a:t>
             </a:r>
@@ -3114,21 +3159,36 @@
       </p:sp>
       <p:sp>
         <p:nvSpPr>
-          <p:cNvPr id="3" name="Subtitle 2"/>
-          <p:cNvSpPr>
-            <a:spLocks noGrp="1"/>
-          </p:cNvSpPr>
-          <p:nvPr>
-            <p:ph type="subTitle" idx="1"/>
-          </p:nvPr>
-        </p:nvSpPr>
-        <p:spPr/>
-        <p:txBody>
-          <a:bodyPr/>
-          <a:lstStyle/>
-          <a:p>
-            <a:r>
-              <a:t>Understanding the Power of RAG in LLMs</a:t>
+          <p:cNvPr id="4" name="TextBox 3"/>
+          <p:cNvSpPr txBox="1"/>
+          <p:nvPr/>
+        </p:nvSpPr>
+        <p:spPr>
+          <a:xfrm>
+            <a:off x="914400" y="4114800"/>
+            <a:ext cx="12801600" cy="914400"/>
+          </a:xfrm>
+          <a:prstGeom prst="rect">
+            <a:avLst/>
+          </a:prstGeom>
+          <a:noFill/>
+        </p:spPr>
+        <p:txBody>
+          <a:bodyPr wrap="none">
+            <a:spAutoFit/>
+          </a:bodyPr>
+          <a:lstStyle/>
+          <a:p>
+            <a:pPr algn="ctr">
+              <a:defRPr sz="2400">
+                <a:solidFill>
+                  <a:srgbClr val="C8C8C8"/>
+                </a:solidFill>
+                <a:latin typeface="Arial"/>
+              </a:defRPr>
+            </a:pPr>
+            <a:r>
+              <a:t>Bridging the Gap Between LLMs and External Knowledge</a:t>
             </a:r>
           </a:p>
         </p:txBody>
@@ -3166,8 +3226,11 @@
           <a:bodyPr/>
           <a:lstStyle/>
           <a:p>
-            <a:r>
-              <a:t>What is Retrieval-Augmented Generation (RAG)?</a:t>
+            <a:pPr>
+              <a:defRPr sz="3600" b="1"/>
+            </a:pPr>
+            <a:r>
+              <a:t>The Challenge with Traditional LLMs</a:t>
             </a:r>
           </a:p>
         </p:txBody>
@@ -3188,18 +3251,46 @@
           <a:lstStyle/>
           <a:p/>
           <a:p>
-            <a:r>
-              <a:t>RAG is an AI framework that enhances the capabilities of Large Language Models (LLMs).</a:t>
-            </a:r>
-          </a:p>
-          <a:p>
-            <a:r>
-              <a:t>It combines the strengths of information retrieval systems with generative AI models.</a:t>
-            </a:r>
-          </a:p>
-          <a:p>
-            <a:r>
-              <a:t>The goal is to provide LLMs with access to up-to-date and domain-specific information, reducing hallucinations and improving factual accuracy.</a:t>
+            <a:pPr>
+              <a:spcAft>
+                <a:spcPts val="1200"/>
+              </a:spcAft>
+              <a:defRPr sz="2000"/>
+            </a:pPr>
+            <a:r>
+              <a:t>Large Language Models (LLMs) are powerful, but they have inherent limitations:</a:t>
+            </a:r>
+          </a:p>
+          <a:p>
+            <a:pPr lvl="1">
+              <a:defRPr sz="1800"/>
+            </a:pPr>
+            <a:r>
+              <a:t>Knowledge Cutoff: Trained on static datasets, they lack real-time information.</a:t>
+            </a:r>
+          </a:p>
+          <a:p>
+            <a:pPr lvl="1">
+              <a:defRPr sz="1800"/>
+            </a:pPr>
+            <a:r>
+              <a:t>Hallucinations: They can generate plausible but incorrect or nonsensical information.</a:t>
+            </a:r>
+          </a:p>
+          <a:p>
+            <a:pPr lvl="1">
+              <a:defRPr sz="1800"/>
+            </a:pPr>
+            <a:r>
+              <a:t>Lack of Transparency: It's hard to trace the source of their generated answers.</a:t>
+            </a:r>
+          </a:p>
+          <a:p>
+            <a:pPr lvl="1">
+              <a:defRPr sz="1800"/>
+            </a:pPr>
+            <a:r>
+              <a:t>Generic Responses: Without specific context, their output can be too general.</a:t>
             </a:r>
           </a:p>
         </p:txBody>
@@ -3237,8 +3328,11 @@
           <a:bodyPr/>
           <a:lstStyle/>
           <a:p>
-            <a:r>
-              <a:t>How RAG Works</a:t>
+            <a:pPr>
+              <a:defRPr sz="3600" b="1"/>
+            </a:pPr>
+            <a:r>
+              <a:t>Introducing RAG</a:t>
             </a:r>
           </a:p>
         </p:txBody>
@@ -3259,18 +3353,33 @@
           <a:lstStyle/>
           <a:p/>
           <a:p>
-            <a:r>
-              <a:t>1. Retrieval: When a query is made, a retriever component searches a knowledge base (e.g., documents, databases) for relevant information.</a:t>
-            </a:r>
-          </a:p>
-          <a:p>
-            <a:r>
-              <a:t>2. Augmentation: The retrieved information is then provided as context to the LLM, alongside the original query.</a:t>
-            </a:r>
-          </a:p>
-          <a:p>
-            <a:r>
-              <a:t>3. Generation: The LLM uses this augmented context to generate a more informed, accurate, and relevant response.</a:t>
+            <a:pPr>
+              <a:spcAft>
+                <a:spcPts val="1200"/>
+              </a:spcAft>
+              <a:defRPr sz="2000"/>
+            </a:pPr>
+            <a:r>
+              <a:t>RAG is a technique that enhances LLM responses by grounding them in external, up-to-date information.</a:t>
+            </a:r>
+          </a:p>
+          <a:p>
+            <a:pPr>
+              <a:spcAft>
+                <a:spcPts val="1200"/>
+              </a:spcAft>
+              <a:defRPr sz="2000"/>
+            </a:pPr>
+            <a:r>
+              <a:t>It combines the generative power of LLMs with a retrieval system that fetches relevant information from a knowledge base.</a:t>
+            </a:r>
+          </a:p>
+          <a:p>
+            <a:pPr>
+              <a:defRPr sz="2000"/>
+            </a:pPr>
+            <a:r>
+              <a:t>Think of it as giving the LLM an 'open-book' exam, where the book is your specific data source.</a:t>
             </a:r>
           </a:p>
         </p:txBody>
@@ -3307,9 +3416,429 @@
         <p:txBody>
           <a:bodyPr/>
           <a:lstStyle/>
-          <a:p>
-            <a:r>
-              <a:t>Benefits of RAG</a:t>
+          <a:p/>
+        </p:txBody>
+      </p:sp>
+      <p:sp>
+        <p:nvSpPr>
+          <p:cNvPr id="3" name="TextBox 2"/>
+          <p:cNvSpPr txBox="1"/>
+          <p:nvPr/>
+        </p:nvSpPr>
+        <p:spPr>
+          <a:xfrm>
+            <a:off x="457200" y="182880"/>
+            <a:ext cx="13716000" cy="731520"/>
+          </a:xfrm>
+          <a:prstGeom prst="rect">
+            <a:avLst/>
+          </a:prstGeom>
+          <a:noFill/>
+        </p:spPr>
+        <p:txBody>
+          <a:bodyPr wrap="none">
+            <a:spAutoFit/>
+          </a:bodyPr>
+          <a:lstStyle/>
+          <a:p>
+            <a:pPr algn="ctr">
+              <a:defRPr sz="3600" b="1"/>
+            </a:pPr>
+            <a:r>
+              <a:t>How RAG Works: A Simplified Flow</a:t>
+            </a:r>
+          </a:p>
+        </p:txBody>
+      </p:sp>
+      <p:sp>
+        <p:nvSpPr>
+          <p:cNvPr id="4" name="Rounded Rectangle 3"/>
+          <p:cNvSpPr/>
+          <p:nvPr/>
+        </p:nvSpPr>
+        <p:spPr>
+          <a:xfrm>
+            <a:off x="914400" y="1828800"/>
+            <a:ext cx="2286000" cy="1371600"/>
+          </a:xfrm>
+          <a:prstGeom prst="roundRect">
+            <a:avLst/>
+          </a:prstGeom>
+          <a:solidFill>
+            <a:srgbClr val="408EC6"/>
+          </a:solidFill>
+          <a:ln>
+            <a:solidFill>
+              <a:srgbClr val="FFFFFF"/>
+            </a:solidFill>
+          </a:ln>
+        </p:spPr>
+        <p:style>
+          <a:lnRef idx="1">
+            <a:schemeClr val="accent1"/>
+          </a:lnRef>
+          <a:fillRef idx="3">
+            <a:schemeClr val="accent1"/>
+          </a:fillRef>
+          <a:effectRef idx="2">
+            <a:schemeClr val="accent1"/>
+          </a:effectRef>
+          <a:fontRef idx="minor">
+            <a:schemeClr val="lt1"/>
+          </a:fontRef>
+        </p:style>
+        <p:txBody>
+          <a:bodyPr rtlCol="0" anchor="ctr"/>
+          <a:lstStyle/>
+          <a:p>
+            <a:pPr algn="ctr">
+              <a:defRPr sz="1600">
+                <a:solidFill>
+                  <a:srgbClr val="FFFFFF"/>
+                </a:solidFill>
+              </a:defRPr>
+            </a:pPr>
+            <a:r>
+              <a:t>1. User Query</a:t>
+            </a:r>
+          </a:p>
+        </p:txBody>
+      </p:sp>
+      <p:sp>
+        <p:nvSpPr>
+          <p:cNvPr id="5" name="Right Arrow 4"/>
+          <p:cNvSpPr/>
+          <p:nvPr/>
+        </p:nvSpPr>
+        <p:spPr>
+          <a:xfrm>
+            <a:off x="3383280" y="2286000"/>
+            <a:ext cx="914400" cy="457200"/>
+          </a:xfrm>
+          <a:prstGeom prst="rightArrow">
+            <a:avLst/>
+          </a:prstGeom>
+          <a:solidFill>
+            <a:srgbClr val="646464"/>
+          </a:solidFill>
+          <a:ln>
+            <a:solidFill>
+              <a:srgbClr val="646464"/>
+            </a:solidFill>
+          </a:ln>
+        </p:spPr>
+        <p:style>
+          <a:lnRef idx="1">
+            <a:schemeClr val="accent1"/>
+          </a:lnRef>
+          <a:fillRef idx="3">
+            <a:schemeClr val="accent1"/>
+          </a:fillRef>
+          <a:effectRef idx="2">
+            <a:schemeClr val="accent1"/>
+          </a:effectRef>
+          <a:fontRef idx="minor">
+            <a:schemeClr val="lt1"/>
+          </a:fontRef>
+        </p:style>
+        <p:txBody>
+          <a:bodyPr rtlCol="0" anchor="ctr"/>
+          <a:lstStyle/>
+          <a:p>
+            <a:pPr algn="ctr"/>
+          </a:p>
+        </p:txBody>
+      </p:sp>
+      <p:sp>
+        <p:nvSpPr>
+          <p:cNvPr id="6" name="Rounded Rectangle 5"/>
+          <p:cNvSpPr/>
+          <p:nvPr/>
+        </p:nvSpPr>
+        <p:spPr>
+          <a:xfrm>
+            <a:off x="4572000" y="1828800"/>
+            <a:ext cx="2743200" cy="1371600"/>
+          </a:xfrm>
+          <a:prstGeom prst="roundRect">
+            <a:avLst/>
+          </a:prstGeom>
+          <a:solidFill>
+            <a:srgbClr val="065A82"/>
+          </a:solidFill>
+          <a:ln>
+            <a:solidFill>
+              <a:srgbClr val="FFFFFF"/>
+            </a:solidFill>
+          </a:ln>
+        </p:spPr>
+        <p:style>
+          <a:lnRef idx="1">
+            <a:schemeClr val="accent1"/>
+          </a:lnRef>
+          <a:fillRef idx="3">
+            <a:schemeClr val="accent1"/>
+          </a:fillRef>
+          <a:effectRef idx="2">
+            <a:schemeClr val="accent1"/>
+          </a:effectRef>
+          <a:fontRef idx="minor">
+            <a:schemeClr val="lt1"/>
+          </a:fontRef>
+        </p:style>
+        <p:txBody>
+          <a:bodyPr rtlCol="0" anchor="ctr"/>
+          <a:lstStyle/>
+          <a:p>
+            <a:pPr algn="ctr">
+              <a:defRPr sz="1600">
+                <a:solidFill>
+                  <a:srgbClr val="FFFFFF"/>
+                </a:solidFill>
+              </a:defRPr>
+            </a:pPr>
+            <a:r>
+              <a:t>2. Retrieve Relevant Documents</a:t>
+            </a:r>
+          </a:p>
+        </p:txBody>
+      </p:sp>
+      <p:sp>
+        <p:nvSpPr>
+          <p:cNvPr id="7" name="Right Arrow 6"/>
+          <p:cNvSpPr/>
+          <p:nvPr/>
+        </p:nvSpPr>
+        <p:spPr>
+          <a:xfrm>
+            <a:off x="7498079" y="2286000"/>
+            <a:ext cx="914400" cy="457200"/>
+          </a:xfrm>
+          <a:prstGeom prst="rightArrow">
+            <a:avLst/>
+          </a:prstGeom>
+          <a:solidFill>
+            <a:srgbClr val="646464"/>
+          </a:solidFill>
+          <a:ln>
+            <a:solidFill>
+              <a:srgbClr val="646464"/>
+            </a:solidFill>
+          </a:ln>
+        </p:spPr>
+        <p:style>
+          <a:lnRef idx="1">
+            <a:schemeClr val="accent1"/>
+          </a:lnRef>
+          <a:fillRef idx="3">
+            <a:schemeClr val="accent1"/>
+          </a:fillRef>
+          <a:effectRef idx="2">
+            <a:schemeClr val="accent1"/>
+          </a:effectRef>
+          <a:fontRef idx="minor">
+            <a:schemeClr val="lt1"/>
+          </a:fontRef>
+        </p:style>
+        <p:txBody>
+          <a:bodyPr rtlCol="0" anchor="ctr"/>
+          <a:lstStyle/>
+          <a:p>
+            <a:pPr algn="ctr"/>
+          </a:p>
+        </p:txBody>
+      </p:sp>
+      <p:sp>
+        <p:nvSpPr>
+          <p:cNvPr id="8" name="Rounded Rectangle 7"/>
+          <p:cNvSpPr/>
+          <p:nvPr/>
+        </p:nvSpPr>
+        <p:spPr>
+          <a:xfrm>
+            <a:off x="8686800" y="1828800"/>
+            <a:ext cx="2286000" cy="1371600"/>
+          </a:xfrm>
+          <a:prstGeom prst="roundRect">
+            <a:avLst/>
+          </a:prstGeom>
+          <a:solidFill>
+            <a:srgbClr val="408EC6"/>
+          </a:solidFill>
+          <a:ln>
+            <a:solidFill>
+              <a:srgbClr val="FFFFFF"/>
+            </a:solidFill>
+          </a:ln>
+        </p:spPr>
+        <p:style>
+          <a:lnRef idx="1">
+            <a:schemeClr val="accent1"/>
+          </a:lnRef>
+          <a:fillRef idx="3">
+            <a:schemeClr val="accent1"/>
+          </a:fillRef>
+          <a:effectRef idx="2">
+            <a:schemeClr val="accent1"/>
+          </a:effectRef>
+          <a:fontRef idx="minor">
+            <a:schemeClr val="lt1"/>
+          </a:fontRef>
+        </p:style>
+        <p:txBody>
+          <a:bodyPr rtlCol="0" anchor="ctr"/>
+          <a:lstStyle/>
+          <a:p>
+            <a:pPr algn="ctr">
+              <a:defRPr sz="1600">
+                <a:solidFill>
+                  <a:srgbClr val="FFFFFF"/>
+                </a:solidFill>
+              </a:defRPr>
+            </a:pPr>
+            <a:r>
+              <a:t>3. Augment Prompt</a:t>
+            </a:r>
+          </a:p>
+        </p:txBody>
+      </p:sp>
+      <p:sp>
+        <p:nvSpPr>
+          <p:cNvPr id="9" name="Right Arrow 8"/>
+          <p:cNvSpPr/>
+          <p:nvPr/>
+        </p:nvSpPr>
+        <p:spPr>
+          <a:xfrm>
+            <a:off x="11155680" y="2286000"/>
+            <a:ext cx="914400" cy="457200"/>
+          </a:xfrm>
+          <a:prstGeom prst="rightArrow">
+            <a:avLst/>
+          </a:prstGeom>
+          <a:solidFill>
+            <a:srgbClr val="646464"/>
+          </a:solidFill>
+          <a:ln>
+            <a:solidFill>
+              <a:srgbClr val="646464"/>
+            </a:solidFill>
+          </a:ln>
+        </p:spPr>
+        <p:style>
+          <a:lnRef idx="1">
+            <a:schemeClr val="accent1"/>
+          </a:lnRef>
+          <a:fillRef idx="3">
+            <a:schemeClr val="accent1"/>
+          </a:fillRef>
+          <a:effectRef idx="2">
+            <a:schemeClr val="accent1"/>
+          </a:effectRef>
+          <a:fontRef idx="minor">
+            <a:schemeClr val="lt1"/>
+          </a:fontRef>
+        </p:style>
+        <p:txBody>
+          <a:bodyPr rtlCol="0" anchor="ctr"/>
+          <a:lstStyle/>
+          <a:p>
+            <a:pPr algn="ctr"/>
+          </a:p>
+        </p:txBody>
+      </p:sp>
+      <p:sp>
+        <p:nvSpPr>
+          <p:cNvPr id="10" name="Rounded Rectangle 9"/>
+          <p:cNvSpPr/>
+          <p:nvPr/>
+        </p:nvSpPr>
+        <p:spPr>
+          <a:xfrm>
+            <a:off x="12344400" y="1828800"/>
+            <a:ext cx="2286000" cy="1371600"/>
+          </a:xfrm>
+          <a:prstGeom prst="roundRect">
+            <a:avLst/>
+          </a:prstGeom>
+          <a:solidFill>
+            <a:srgbClr val="065A82"/>
+          </a:solidFill>
+          <a:ln>
+            <a:solidFill>
+              <a:srgbClr val="FFFFFF"/>
+            </a:solidFill>
+          </a:ln>
+        </p:spPr>
+        <p:style>
+          <a:lnRef idx="1">
+            <a:schemeClr val="accent1"/>
+          </a:lnRef>
+          <a:fillRef idx="3">
+            <a:schemeClr val="accent1"/>
+          </a:fillRef>
+          <a:effectRef idx="2">
+            <a:schemeClr val="accent1"/>
+          </a:effectRef>
+          <a:fontRef idx="minor">
+            <a:schemeClr val="lt1"/>
+          </a:fontRef>
+        </p:style>
+        <p:txBody>
+          <a:bodyPr rtlCol="0" anchor="ctr"/>
+          <a:lstStyle/>
+          <a:p>
+            <a:pPr algn="ctr">
+              <a:defRPr sz="1600">
+                <a:solidFill>
+                  <a:srgbClr val="FFFFFF"/>
+                </a:solidFill>
+              </a:defRPr>
+            </a:pPr>
+            <a:r>
+              <a:t>4. Generate Answer</a:t>
+            </a:r>
+          </a:p>
+        </p:txBody>
+      </p:sp>
+    </p:spTree>
+  </p:cSld>
+  <p:clrMapOvr>
+    <a:masterClrMapping/>
+  </p:clrMapOvr>
+</p:sld>
+</file>
+
+<file path=ppt/slides/slide5.xml><?xml version="1.0" encoding="utf-8"?>
+<p:sld xmlns:a="http://schemas.openxmlformats.org/drawingml/2006/main" xmlns:p="http://schemas.openxmlformats.org/presentationml/2006/main" xmlns:r="http://schemas.openxmlformats.org/officeDocument/2006/relationships">
+  <p:cSld>
+    <p:spTree>
+      <p:nvGrpSpPr>
+        <p:cNvPr id="1" name=""/>
+        <p:cNvGrpSpPr/>
+        <p:nvPr/>
+      </p:nvGrpSpPr>
+      <p:grpSpPr/>
+      <p:sp>
+        <p:nvSpPr>
+          <p:cNvPr id="2" name="Title 1"/>
+          <p:cNvSpPr>
+            <a:spLocks noGrp="1"/>
+          </p:cNvSpPr>
+          <p:nvPr>
+            <p:ph type="title"/>
+          </p:nvPr>
+        </p:nvSpPr>
+        <p:spPr/>
+        <p:txBody>
+          <a:bodyPr/>
+          <a:lstStyle/>
+          <a:p>
+            <a:pPr>
+              <a:defRPr sz="3600" b="1"/>
+            </a:pPr>
+            <a:r>
+              <a:t>Core Components of a RAG System</a:t>
             </a:r>
           </a:p>
         </p:txBody>
@@ -3330,28 +3859,487 @@
           <a:lstStyle/>
           <a:p/>
           <a:p>
-            <a:r>
-              <a:t>Reduced Hallucinations: LLMs are less likely to generate factually incorrect or nonsensical information.</a:t>
-            </a:r>
-          </a:p>
-          <a:p>
-            <a:r>
-              <a:t>Improved Factual Accuracy: Responses are grounded in real, verifiable data from the knowledge base.</a:t>
-            </a:r>
-          </a:p>
-          <a:p>
-            <a:r>
-              <a:t>Access to Up-to-Date Information: LLMs can leverage the latest information without needing to be retrained.</a:t>
-            </a:r>
-          </a:p>
-          <a:p>
-            <a:r>
-              <a:t>Domain-Specific Knowledge: Enables LLMs to answer questions requiring specialized knowledge not present in their original training data.</a:t>
-            </a:r>
-          </a:p>
-          <a:p>
-            <a:r>
-              <a:t>Transparency and Explainability: It's often possible to trace the source of the information used to generate a response.</a:t>
+            <a:pPr>
+              <a:spcAft>
+                <a:spcPts val="600"/>
+              </a:spcAft>
+              <a:defRPr sz="2000" b="1"/>
+            </a:pPr>
+            <a:r>
+              <a:t>Retriever:</a:t>
+            </a:r>
+          </a:p>
+          <a:p>
+            <a:pPr lvl="1">
+              <a:defRPr sz="1800"/>
+            </a:pPr>
+            <a:r>
+              <a:t>Scans the knowledge base (e.g., documents, databases) to find information relevant to the user's query.</a:t>
+            </a:r>
+          </a:p>
+          <a:p>
+            <a:pPr>
+              <a:spcAft>
+                <a:spcPts val="600"/>
+              </a:spcAft>
+              <a:defRPr sz="2000" b="1"/>
+            </a:pPr>
+            <a:r>
+              <a:t>Generator:</a:t>
+            </a:r>
+          </a:p>
+          <a:p>
+            <a:pPr lvl="1">
+              <a:defRPr sz="1800"/>
+            </a:pPr>
+            <a:r>
+              <a:t>An LLM that takes the original query and the retrieved context to produce a coherent, human-like answer.</a:t>
+            </a:r>
+          </a:p>
+          <a:p>
+            <a:pPr>
+              <a:spcAft>
+                <a:spcPts val="600"/>
+              </a:spcAft>
+              <a:defRPr sz="2000" b="1"/>
+            </a:pPr>
+            <a:r>
+              <a:t>Knowledge Base / Index:</a:t>
+            </a:r>
+          </a:p>
+          <a:p>
+            <a:pPr lvl="1">
+              <a:defRPr sz="1800"/>
+            </a:pPr>
+            <a:r>
+              <a:t>The external data source, often converted into a searchable vector index for efficient retrieval.</a:t>
+            </a:r>
+          </a:p>
+        </p:txBody>
+      </p:sp>
+    </p:spTree>
+  </p:cSld>
+  <p:clrMapOvr>
+    <a:masterClrMapping/>
+  </p:clrMapOvr>
+</p:sld>
+</file>
+
+<file path=ppt/slides/slide6.xml><?xml version="1.0" encoding="utf-8"?>
+<p:sld xmlns:a="http://schemas.openxmlformats.org/drawingml/2006/main" xmlns:p="http://schemas.openxmlformats.org/presentationml/2006/main" xmlns:r="http://schemas.openxmlformats.org/officeDocument/2006/relationships">
+  <p:cSld>
+    <p:spTree>
+      <p:nvGrpSpPr>
+        <p:cNvPr id="1" name=""/>
+        <p:cNvGrpSpPr/>
+        <p:nvPr/>
+      </p:nvGrpSpPr>
+      <p:grpSpPr/>
+      <p:sp>
+        <p:nvSpPr>
+          <p:cNvPr id="2" name="Title 1"/>
+          <p:cNvSpPr>
+            <a:spLocks noGrp="1"/>
+          </p:cNvSpPr>
+          <p:nvPr>
+            <p:ph type="title"/>
+          </p:nvPr>
+        </p:nvSpPr>
+        <p:spPr/>
+        <p:txBody>
+          <a:bodyPr/>
+          <a:lstStyle/>
+          <a:p>
+            <a:pPr>
+              <a:defRPr sz="3600" b="1"/>
+            </a:pPr>
+            <a:r>
+              <a:t>Key Benefits of Using RAG</a:t>
+            </a:r>
+          </a:p>
+        </p:txBody>
+      </p:sp>
+      <p:sp>
+        <p:nvSpPr>
+          <p:cNvPr id="3" name="Content Placeholder 2"/>
+          <p:cNvSpPr>
+            <a:spLocks noGrp="1"/>
+          </p:cNvSpPr>
+          <p:nvPr>
+            <p:ph idx="1"/>
+          </p:nvPr>
+        </p:nvSpPr>
+        <p:spPr/>
+        <p:txBody>
+          <a:bodyPr/>
+          <a:lstStyle/>
+          <a:p/>
+          <a:p>
+            <a:pPr>
+              <a:spcAft>
+                <a:spcPts val="600"/>
+              </a:spcAft>
+              <a:defRPr sz="2000" b="1"/>
+            </a:pPr>
+            <a:r>
+              <a:t>Improved Accuracy &amp; Reduced Hallucinations</a:t>
+            </a:r>
+          </a:p>
+          <a:p>
+            <a:pPr lvl="1">
+              <a:defRPr sz="1800"/>
+            </a:pPr>
+            <a:r>
+              <a:t>Answers are based on real data, making them more factual and reliable.</a:t>
+            </a:r>
+          </a:p>
+          <a:p>
+            <a:pPr>
+              <a:spcAft>
+                <a:spcPts val="600"/>
+              </a:spcAft>
+              <a:defRPr sz="2000" b="1"/>
+            </a:pPr>
+            <a:r>
+              <a:t>Access to Real-Time Information</a:t>
+            </a:r>
+          </a:p>
+          <a:p>
+            <a:pPr lvl="1">
+              <a:defRPr sz="1800"/>
+            </a:pPr>
+            <a:r>
+              <a:t>The knowledge base can be continuously updated, unlike a static LLM.</a:t>
+            </a:r>
+          </a:p>
+          <a:p>
+            <a:pPr>
+              <a:spcAft>
+                <a:spcPts val="600"/>
+              </a:spcAft>
+              <a:defRPr sz="2000" b="1"/>
+            </a:pPr>
+            <a:r>
+              <a:t>Increased Trust and Transparency</a:t>
+            </a:r>
+          </a:p>
+          <a:p>
+            <a:pPr lvl="1">
+              <a:defRPr sz="1800"/>
+            </a:pPr>
+            <a:r>
+              <a:t>Systems can cite sources, allowing users to verify the information.</a:t>
+            </a:r>
+          </a:p>
+        </p:txBody>
+      </p:sp>
+    </p:spTree>
+  </p:cSld>
+  <p:clrMapOvr>
+    <a:masterClrMapping/>
+  </p:clrMapOvr>
+</p:sld>
+</file>
+
+<file path=ppt/slides/slide7.xml><?xml version="1.0" encoding="utf-8"?>
+<p:sld xmlns:a="http://schemas.openxmlformats.org/drawingml/2006/main" xmlns:p="http://schemas.openxmlformats.org/presentationml/2006/main" xmlns:r="http://schemas.openxmlformats.org/officeDocument/2006/relationships">
+  <p:cSld>
+    <p:spTree>
+      <p:nvGrpSpPr>
+        <p:cNvPr id="1" name=""/>
+        <p:cNvGrpSpPr/>
+        <p:nvPr/>
+      </p:nvGrpSpPr>
+      <p:grpSpPr/>
+      <p:sp>
+        <p:nvSpPr>
+          <p:cNvPr id="2" name="Title 1"/>
+          <p:cNvSpPr>
+            <a:spLocks noGrp="1"/>
+          </p:cNvSpPr>
+          <p:nvPr>
+            <p:ph type="title"/>
+          </p:nvPr>
+        </p:nvSpPr>
+        <p:spPr/>
+        <p:txBody>
+          <a:bodyPr/>
+          <a:lstStyle/>
+          <a:p>
+            <a:pPr>
+              <a:defRPr sz="3600" b="1"/>
+            </a:pPr>
+            <a:r>
+              <a:t>Common Use Cases</a:t>
+            </a:r>
+          </a:p>
+        </p:txBody>
+      </p:sp>
+      <p:sp>
+        <p:nvSpPr>
+          <p:cNvPr id="3" name="Content Placeholder 2"/>
+          <p:cNvSpPr>
+            <a:spLocks noGrp="1"/>
+          </p:cNvSpPr>
+          <p:nvPr>
+            <p:ph idx="1"/>
+          </p:nvPr>
+        </p:nvSpPr>
+        <p:spPr/>
+        <p:txBody>
+          <a:bodyPr/>
+          <a:lstStyle/>
+          <a:p/>
+          <a:p>
+            <a:pPr>
+              <a:defRPr sz="1800"/>
+            </a:pPr>
+            <a:r>
+              <a:t>Customer Support Chatbots</a:t>
+            </a:r>
+          </a:p>
+          <a:p>
+            <a:pPr lvl="1">
+              <a:defRPr sz="1800"/>
+            </a:pPr>
+            <a:r>
+              <a:t>Answering queries based on product manuals and internal knowledge bases.</a:t>
+            </a:r>
+          </a:p>
+          <a:p>
+            <a:pPr>
+              <a:defRPr sz="1800"/>
+            </a:pPr>
+            <a:r>
+              <a:t>Enterprise Search</a:t>
+            </a:r>
+          </a:p>
+          <a:p>
+            <a:pPr lvl="1">
+              <a:defRPr sz="1800"/>
+            </a:pPr>
+            <a:r>
+              <a:t>Helping employees find information within large corporate document repositories.</a:t>
+            </a:r>
+          </a:p>
+          <a:p>
+            <a:pPr>
+              <a:defRPr sz="1800"/>
+            </a:pPr>
+            <a:r>
+              <a:t>Content Creation &amp; Summarization</a:t>
+            </a:r>
+          </a:p>
+          <a:p>
+            <a:pPr lvl="1">
+              <a:defRPr sz="1800"/>
+            </a:pPr>
+            <a:r>
+              <a:t>Generating summaries of research papers, news articles, or financial reports.</a:t>
+            </a:r>
+          </a:p>
+        </p:txBody>
+      </p:sp>
+    </p:spTree>
+  </p:cSld>
+  <p:clrMapOvr>
+    <a:masterClrMapping/>
+  </p:clrMapOvr>
+</p:sld>
+</file>
+
+<file path=ppt/slides/slide8.xml><?xml version="1.0" encoding="utf-8"?>
+<p:sld xmlns:a="http://schemas.openxmlformats.org/drawingml/2006/main" xmlns:p="http://schemas.openxmlformats.org/presentationml/2006/main" xmlns:r="http://schemas.openxmlformats.org/officeDocument/2006/relationships">
+  <p:cSld>
+    <p:spTree>
+      <p:nvGrpSpPr>
+        <p:cNvPr id="1" name=""/>
+        <p:cNvGrpSpPr/>
+        <p:nvPr/>
+      </p:nvGrpSpPr>
+      <p:grpSpPr/>
+      <p:sp>
+        <p:nvSpPr>
+          <p:cNvPr id="2" name="Title 1"/>
+          <p:cNvSpPr>
+            <a:spLocks noGrp="1"/>
+          </p:cNvSpPr>
+          <p:nvPr>
+            <p:ph type="title"/>
+          </p:nvPr>
+        </p:nvSpPr>
+        <p:spPr/>
+        <p:txBody>
+          <a:bodyPr/>
+          <a:lstStyle/>
+          <a:p>
+            <a:pPr>
+              <a:defRPr sz="3600" b="1"/>
+            </a:pPr>
+            <a:r>
+              <a:t>Conclusion</a:t>
+            </a:r>
+          </a:p>
+        </p:txBody>
+      </p:sp>
+      <p:sp>
+        <p:nvSpPr>
+          <p:cNvPr id="3" name="Content Placeholder 2"/>
+          <p:cNvSpPr>
+            <a:spLocks noGrp="1"/>
+          </p:cNvSpPr>
+          <p:nvPr>
+            <p:ph idx="1"/>
+          </p:nvPr>
+        </p:nvSpPr>
+        <p:spPr/>
+        <p:txBody>
+          <a:bodyPr/>
+          <a:lstStyle/>
+          <a:p/>
+          <a:p>
+            <a:pPr>
+              <a:spcAft>
+                <a:spcPts val="1200"/>
+              </a:spcAft>
+              <a:defRPr sz="2200"/>
+            </a:pPr>
+            <a:r>
+              <a:t>RAG is a transformative approach that makes LLMs more powerful, reliable, and useful.</a:t>
+            </a:r>
+          </a:p>
+          <a:p>
+            <a:pPr>
+              <a:spcAft>
+                <a:spcPts val="1200"/>
+              </a:spcAft>
+              <a:defRPr sz="2200"/>
+            </a:pPr>
+            <a:r>
+              <a:t>By connecting them to live, verifiable data sources, RAG unlocks new possibilities for AI applications across industries.</a:t>
+            </a:r>
+          </a:p>
+          <a:p>
+            <a:pPr>
+              <a:defRPr sz="2200"/>
+            </a:pPr>
+            <a:r>
+              <a:t>It represents a significant step towards creating AI systems that are not just fluent, but also factual and trustworthy.</a:t>
+            </a:r>
+          </a:p>
+        </p:txBody>
+      </p:sp>
+    </p:spTree>
+  </p:cSld>
+  <p:clrMapOvr>
+    <a:masterClrMapping/>
+  </p:clrMapOvr>
+</p:sld>
+</file>
+
+<file path=ppt/slides/slide9.xml><?xml version="1.0" encoding="utf-8"?>
+<p:sld xmlns:a="http://schemas.openxmlformats.org/drawingml/2006/main" xmlns:p="http://schemas.openxmlformats.org/presentationml/2006/main" xmlns:r="http://schemas.openxmlformats.org/officeDocument/2006/relationships">
+  <p:cSld>
+    <p:bg>
+      <p:bgPr>
+        <a:solidFill>
+          <a:srgbClr val="065A82"/>
+        </a:solidFill>
+        <a:effectLst/>
+      </p:bgPr>
+    </p:bg>
+    <p:spTree>
+      <p:nvGrpSpPr>
+        <p:cNvPr id="1" name=""/>
+        <p:cNvGrpSpPr/>
+        <p:nvPr/>
+      </p:nvGrpSpPr>
+      <p:grpSpPr/>
+      <p:sp>
+        <p:nvSpPr>
+          <p:cNvPr id="2" name="Title 1"/>
+          <p:cNvSpPr>
+            <a:spLocks noGrp="1"/>
+          </p:cNvSpPr>
+          <p:nvPr>
+            <p:ph type="title"/>
+          </p:nvPr>
+        </p:nvSpPr>
+        <p:spPr/>
+        <p:txBody>
+          <a:bodyPr/>
+          <a:lstStyle/>
+          <a:p/>
+        </p:txBody>
+      </p:sp>
+      <p:sp>
+        <p:nvSpPr>
+          <p:cNvPr id="3" name="TextBox 2"/>
+          <p:cNvSpPr txBox="1"/>
+          <p:nvPr/>
+        </p:nvSpPr>
+        <p:spPr>
+          <a:xfrm>
+            <a:off x="914400" y="2743200"/>
+            <a:ext cx="12801600" cy="1828800"/>
+          </a:xfrm>
+          <a:prstGeom prst="rect">
+            <a:avLst/>
+          </a:prstGeom>
+          <a:noFill/>
+        </p:spPr>
+        <p:txBody>
+          <a:bodyPr wrap="none">
+            <a:spAutoFit/>
+          </a:bodyPr>
+          <a:lstStyle/>
+          <a:p>
+            <a:pPr algn="ctr">
+              <a:defRPr sz="4400" b="1">
+                <a:solidFill>
+                  <a:srgbClr val="FFFFFF"/>
+                </a:solidFill>
+                <a:latin typeface="Arial"/>
+              </a:defRPr>
+            </a:pPr>
+            <a:r>
+              <a:t>Thank You</a:t>
+            </a:r>
+          </a:p>
+        </p:txBody>
+      </p:sp>
+      <p:sp>
+        <p:nvSpPr>
+          <p:cNvPr id="4" name="TextBox 3"/>
+          <p:cNvSpPr txBox="1"/>
+          <p:nvPr/>
+        </p:nvSpPr>
+        <p:spPr>
+          <a:xfrm>
+            <a:off x="914400" y="4114800"/>
+            <a:ext cx="12801600" cy="914400"/>
+          </a:xfrm>
+          <a:prstGeom prst="rect">
+            <a:avLst/>
+          </a:prstGeom>
+          <a:noFill/>
+        </p:spPr>
+        <p:txBody>
+          <a:bodyPr wrap="none">
+            <a:spAutoFit/>
+          </a:bodyPr>
+          <a:lstStyle/>
+          <a:p>
+            <a:pPr algn="ctr">
+              <a:defRPr sz="3200">
+                <a:solidFill>
+                  <a:srgbClr val="C8C8C8"/>
+                </a:solidFill>
+                <a:latin typeface="Arial"/>
+              </a:defRPr>
+            </a:pPr>
+            <a:r>
+              <a:t>Questions?</a:t>
             </a:r>
           </a:p>
         </p:txBody>

</xml_diff>